<commit_message>
The bugs in the slides. Noted on first page.
</commit_message>
<xml_diff>
--- a/slides/lecture03-assembly2.pptx
+++ b/slides/lecture03-assembly2.pptx
@@ -646,16 +646,8 @@
           <a:p>
             <a:r>
               <a:rPr lang="sv-SE"/>
-              <a:t>Nu skall vi byta spår en stund och prata om arrays istället. </a:t>
-            </a:r>
-          </a:p>
-          <a:p>
-            <a:r>
-              <a:rPr lang="sv-SE"/>
-              <a:t>Ni har stött på arrays förut (i Java) och skrivit sådana här saker. </a:t>
-            </a:r>
-          </a:p>
-          <a:p>
+              <a:t>Berätta kort om ascii codes. </a:t>
+            </a:r>
             <a:endParaRPr lang="LID4096"/>
           </a:p>
         </p:txBody>
@@ -677,6 +669,102 @@
           <a:p>
             <a:fld id="{01B4E41B-EE32-43AA-BF26-21D12108C66F}" type="slidenum">
               <a:rPr lang="LID4096" smtClean="0"/>
+              <a:t>18</a:t>
+            </a:fld>
+            <a:endParaRPr lang="LID4096"/>
+          </a:p>
+        </p:txBody>
+      </p:sp>
+    </p:spTree>
+    <p:extLst>
+      <p:ext uri="{BB962C8B-B14F-4D97-AF65-F5344CB8AC3E}">
+        <p14:creationId xmlns:p14="http://schemas.microsoft.com/office/powerpoint/2010/main" val="3735401211"/>
+      </p:ext>
+    </p:extLst>
+  </p:cSld>
+  <p:clrMapOvr>
+    <a:masterClrMapping/>
+  </p:clrMapOvr>
+</p:notes>
+</file>
+
+<file path=ppt/notesSlides/notesSlide11.xml><?xml version="1.0" encoding="utf-8"?>
+<p:notes xmlns:a="http://schemas.openxmlformats.org/drawingml/2006/main" xmlns:r="http://schemas.openxmlformats.org/officeDocument/2006/relationships" xmlns:p="http://schemas.openxmlformats.org/presentationml/2006/main">
+  <p:cSld>
+    <p:spTree>
+      <p:nvGrpSpPr>
+        <p:cNvPr id="1" name=""/>
+        <p:cNvGrpSpPr/>
+        <p:nvPr/>
+      </p:nvGrpSpPr>
+      <p:grpSpPr>
+        <a:xfrm>
+          <a:off x="0" y="0"/>
+          <a:ext cx="0" cy="0"/>
+          <a:chOff x="0" y="0"/>
+          <a:chExt cx="0" cy="0"/>
+        </a:xfrm>
+      </p:grpSpPr>
+      <p:sp>
+        <p:nvSpPr>
+          <p:cNvPr id="2" name="Slide Image Placeholder 1"/>
+          <p:cNvSpPr>
+            <a:spLocks noGrp="1" noRot="1" noChangeAspect="1"/>
+          </p:cNvSpPr>
+          <p:nvPr>
+            <p:ph type="sldImg"/>
+          </p:nvPr>
+        </p:nvSpPr>
+        <p:spPr/>
+      </p:sp>
+      <p:sp>
+        <p:nvSpPr>
+          <p:cNvPr id="3" name="Notes Placeholder 2"/>
+          <p:cNvSpPr>
+            <a:spLocks noGrp="1"/>
+          </p:cNvSpPr>
+          <p:nvPr>
+            <p:ph type="body" idx="1"/>
+          </p:nvPr>
+        </p:nvSpPr>
+        <p:spPr/>
+        <p:txBody>
+          <a:bodyPr/>
+          <a:lstStyle/>
+          <a:p>
+            <a:r>
+              <a:rPr lang="sv-SE"/>
+              <a:t>Nu skall vi byta spår en stund och prata om arrays istället. </a:t>
+            </a:r>
+          </a:p>
+          <a:p>
+            <a:r>
+              <a:rPr lang="sv-SE"/>
+              <a:t>Ni har stött på arrays förut (i Java) och skrivit sådana här saker. </a:t>
+            </a:r>
+          </a:p>
+          <a:p>
+            <a:endParaRPr lang="LID4096"/>
+          </a:p>
+        </p:txBody>
+      </p:sp>
+      <p:sp>
+        <p:nvSpPr>
+          <p:cNvPr id="4" name="Slide Number Placeholder 3"/>
+          <p:cNvSpPr>
+            <a:spLocks noGrp="1"/>
+          </p:cNvSpPr>
+          <p:nvPr>
+            <p:ph type="sldNum" sz="quarter" idx="5"/>
+          </p:nvPr>
+        </p:nvSpPr>
+        <p:spPr/>
+        <p:txBody>
+          <a:bodyPr/>
+          <a:lstStyle/>
+          <a:p>
+            <a:fld id="{01B4E41B-EE32-43AA-BF26-21D12108C66F}" type="slidenum">
+              <a:rPr lang="LID4096" smtClean="0"/>
               <a:t>20</a:t>
             </a:fld>
             <a:endParaRPr lang="LID4096"/>
@@ -696,7 +784,7 @@
 </p:notes>
 </file>
 
-<file path=ppt/notesSlides/notesSlide11.xml><?xml version="1.0" encoding="utf-8"?>
+<file path=ppt/notesSlides/notesSlide12.xml><?xml version="1.0" encoding="utf-8"?>
 <p:notes xmlns:a="http://schemas.openxmlformats.org/drawingml/2006/main" xmlns:r="http://schemas.openxmlformats.org/officeDocument/2006/relationships" xmlns:p="http://schemas.openxmlformats.org/presentationml/2006/main">
   <p:cSld>
     <p:spTree>
@@ -2209,10 +2297,22 @@
           <a:lstStyle/>
           <a:p>
             <a:r>
-              <a:rPr lang="sv-SE"/>
-              <a:t>Berätta kort om ascii codes. </a:t>
-            </a:r>
-            <a:endParaRPr lang="LID4096"/>
+              <a:rPr lang="en-US" dirty="0"/>
+              <a:t>H</a:t>
+            </a:r>
+            <a:r>
+              <a:rPr lang="sv-SE" dirty="0"/>
+              <a:t>är </a:t>
+            </a:r>
+            <a:r>
+              <a:rPr lang="sv-SE" dirty="0" err="1"/>
+              <a:t>är</a:t>
+            </a:r>
+            <a:r>
+              <a:rPr lang="sv-SE" dirty="0"/>
+              <a:t> hoppeligen dags för paus</a:t>
+            </a:r>
+            <a:endParaRPr lang="LID4096" dirty="0"/>
           </a:p>
         </p:txBody>
       </p:sp>
@@ -2233,7 +2333,7 @@
           <a:p>
             <a:fld id="{01B4E41B-EE32-43AA-BF26-21D12108C66F}" type="slidenum">
               <a:rPr lang="LID4096" smtClean="0"/>
-              <a:t>18</a:t>
+              <a:t>17</a:t>
             </a:fld>
             <a:endParaRPr lang="LID4096"/>
           </a:p>
@@ -2242,7 +2342,7 @@
     </p:spTree>
     <p:extLst>
       <p:ext uri="{BB962C8B-B14F-4D97-AF65-F5344CB8AC3E}">
-        <p14:creationId xmlns:p14="http://schemas.microsoft.com/office/powerpoint/2010/main" val="3735401211"/>
+        <p14:creationId xmlns:p14="http://schemas.microsoft.com/office/powerpoint/2010/main" val="493726078"/>
       </p:ext>
     </p:extLst>
   </p:cSld>
@@ -5830,6 +5930,249 @@
               <a:t>Mer assembler på RISC-V</a:t>
             </a:r>
             <a:endParaRPr lang="LID4096"/>
+          </a:p>
+        </p:txBody>
+      </p:sp>
+      <p:sp>
+        <p:nvSpPr>
+          <p:cNvPr id="4" name="Subtitle 2">
+            <a:extLst>
+              <a:ext uri="{FF2B5EF4-FFF2-40B4-BE49-F238E27FC236}">
+                <a16:creationId xmlns:a16="http://schemas.microsoft.com/office/drawing/2014/main" id="{FD1F8105-158B-FCD7-B65F-CF66AF3970DE}"/>
+              </a:ext>
+            </a:extLst>
+          </p:cNvPr>
+          <p:cNvSpPr txBox="1">
+            <a:spLocks/>
+          </p:cNvSpPr>
+          <p:nvPr/>
+        </p:nvSpPr>
+        <p:spPr>
+          <a:xfrm>
+            <a:off x="1455471" y="4374266"/>
+            <a:ext cx="9144000" cy="1655762"/>
+          </a:xfrm>
+          <a:prstGeom prst="rect">
+            <a:avLst/>
+          </a:prstGeom>
+        </p:spPr>
+        <p:txBody>
+          <a:bodyPr vert="horz" lIns="91440" tIns="45720" rIns="91440" bIns="45720" rtlCol="0">
+            <a:normAutofit lnSpcReduction="10000"/>
+          </a:bodyPr>
+          <a:lstStyle>
+            <a:lvl1pPr marL="0" indent="0" algn="ctr" defTabSz="914400" rtl="0" eaLnBrk="1" latinLnBrk="0" hangingPunct="1">
+              <a:lnSpc>
+                <a:spcPct val="90000"/>
+              </a:lnSpc>
+              <a:spcBef>
+                <a:spcPts val="1000"/>
+              </a:spcBef>
+              <a:buFont typeface="Arial" panose="020B0604020202020204" pitchFamily="34" charset="0"/>
+              <a:buNone/>
+              <a:defRPr sz="2400" kern="1200">
+                <a:solidFill>
+                  <a:schemeClr val="tx1"/>
+                </a:solidFill>
+                <a:latin typeface="+mn-lt"/>
+                <a:ea typeface="+mn-ea"/>
+                <a:cs typeface="+mn-cs"/>
+              </a:defRPr>
+            </a:lvl1pPr>
+            <a:lvl2pPr marL="457200" indent="0" algn="ctr" defTabSz="914400" rtl="0" eaLnBrk="1" latinLnBrk="0" hangingPunct="1">
+              <a:lnSpc>
+                <a:spcPct val="90000"/>
+              </a:lnSpc>
+              <a:spcBef>
+                <a:spcPts val="500"/>
+              </a:spcBef>
+              <a:buFont typeface="Arial" panose="020B0604020202020204" pitchFamily="34" charset="0"/>
+              <a:buNone/>
+              <a:defRPr sz="2000" kern="1200">
+                <a:solidFill>
+                  <a:schemeClr val="tx1"/>
+                </a:solidFill>
+                <a:latin typeface="+mn-lt"/>
+                <a:ea typeface="+mn-ea"/>
+                <a:cs typeface="+mn-cs"/>
+              </a:defRPr>
+            </a:lvl2pPr>
+            <a:lvl3pPr marL="914400" indent="0" algn="ctr" defTabSz="914400" rtl="0" eaLnBrk="1" latinLnBrk="0" hangingPunct="1">
+              <a:lnSpc>
+                <a:spcPct val="90000"/>
+              </a:lnSpc>
+              <a:spcBef>
+                <a:spcPts val="500"/>
+              </a:spcBef>
+              <a:buFont typeface="Arial" panose="020B0604020202020204" pitchFamily="34" charset="0"/>
+              <a:buNone/>
+              <a:defRPr sz="1800" kern="1200">
+                <a:solidFill>
+                  <a:schemeClr val="tx1"/>
+                </a:solidFill>
+                <a:latin typeface="+mn-lt"/>
+                <a:ea typeface="+mn-ea"/>
+                <a:cs typeface="+mn-cs"/>
+              </a:defRPr>
+            </a:lvl3pPr>
+            <a:lvl4pPr marL="1371600" indent="0" algn="ctr" defTabSz="914400" rtl="0" eaLnBrk="1" latinLnBrk="0" hangingPunct="1">
+              <a:lnSpc>
+                <a:spcPct val="90000"/>
+              </a:lnSpc>
+              <a:spcBef>
+                <a:spcPts val="500"/>
+              </a:spcBef>
+              <a:buFont typeface="Arial" panose="020B0604020202020204" pitchFamily="34" charset="0"/>
+              <a:buNone/>
+              <a:defRPr sz="1600" kern="1200">
+                <a:solidFill>
+                  <a:schemeClr val="tx1"/>
+                </a:solidFill>
+                <a:latin typeface="+mn-lt"/>
+                <a:ea typeface="+mn-ea"/>
+                <a:cs typeface="+mn-cs"/>
+              </a:defRPr>
+            </a:lvl4pPr>
+            <a:lvl5pPr marL="1828800" indent="0" algn="ctr" defTabSz="914400" rtl="0" eaLnBrk="1" latinLnBrk="0" hangingPunct="1">
+              <a:lnSpc>
+                <a:spcPct val="90000"/>
+              </a:lnSpc>
+              <a:spcBef>
+                <a:spcPts val="500"/>
+              </a:spcBef>
+              <a:buFont typeface="Arial" panose="020B0604020202020204" pitchFamily="34" charset="0"/>
+              <a:buNone/>
+              <a:defRPr sz="1600" kern="1200">
+                <a:solidFill>
+                  <a:schemeClr val="tx1"/>
+                </a:solidFill>
+                <a:latin typeface="+mn-lt"/>
+                <a:ea typeface="+mn-ea"/>
+                <a:cs typeface="+mn-cs"/>
+              </a:defRPr>
+            </a:lvl5pPr>
+            <a:lvl6pPr marL="2286000" indent="0" algn="ctr" defTabSz="914400" rtl="0" eaLnBrk="1" latinLnBrk="0" hangingPunct="1">
+              <a:lnSpc>
+                <a:spcPct val="90000"/>
+              </a:lnSpc>
+              <a:spcBef>
+                <a:spcPts val="500"/>
+              </a:spcBef>
+              <a:buFont typeface="Arial" panose="020B0604020202020204" pitchFamily="34" charset="0"/>
+              <a:buNone/>
+              <a:defRPr sz="1600" kern="1200">
+                <a:solidFill>
+                  <a:schemeClr val="tx1"/>
+                </a:solidFill>
+                <a:latin typeface="+mn-lt"/>
+                <a:ea typeface="+mn-ea"/>
+                <a:cs typeface="+mn-cs"/>
+              </a:defRPr>
+            </a:lvl6pPr>
+            <a:lvl7pPr marL="2743200" indent="0" algn="ctr" defTabSz="914400" rtl="0" eaLnBrk="1" latinLnBrk="0" hangingPunct="1">
+              <a:lnSpc>
+                <a:spcPct val="90000"/>
+              </a:lnSpc>
+              <a:spcBef>
+                <a:spcPts val="500"/>
+              </a:spcBef>
+              <a:buFont typeface="Arial" panose="020B0604020202020204" pitchFamily="34" charset="0"/>
+              <a:buNone/>
+              <a:defRPr sz="1600" kern="1200">
+                <a:solidFill>
+                  <a:schemeClr val="tx1"/>
+                </a:solidFill>
+                <a:latin typeface="+mn-lt"/>
+                <a:ea typeface="+mn-ea"/>
+                <a:cs typeface="+mn-cs"/>
+              </a:defRPr>
+            </a:lvl7pPr>
+            <a:lvl8pPr marL="3200400" indent="0" algn="ctr" defTabSz="914400" rtl="0" eaLnBrk="1" latinLnBrk="0" hangingPunct="1">
+              <a:lnSpc>
+                <a:spcPct val="90000"/>
+              </a:lnSpc>
+              <a:spcBef>
+                <a:spcPts val="500"/>
+              </a:spcBef>
+              <a:buFont typeface="Arial" panose="020B0604020202020204" pitchFamily="34" charset="0"/>
+              <a:buNone/>
+              <a:defRPr sz="1600" kern="1200">
+                <a:solidFill>
+                  <a:schemeClr val="tx1"/>
+                </a:solidFill>
+                <a:latin typeface="+mn-lt"/>
+                <a:ea typeface="+mn-ea"/>
+                <a:cs typeface="+mn-cs"/>
+              </a:defRPr>
+            </a:lvl8pPr>
+            <a:lvl9pPr marL="3657600" indent="0" algn="ctr" defTabSz="914400" rtl="0" eaLnBrk="1" latinLnBrk="0" hangingPunct="1">
+              <a:lnSpc>
+                <a:spcPct val="90000"/>
+              </a:lnSpc>
+              <a:spcBef>
+                <a:spcPts val="500"/>
+              </a:spcBef>
+              <a:buFont typeface="Arial" panose="020B0604020202020204" pitchFamily="34" charset="0"/>
+              <a:buNone/>
+              <a:defRPr sz="1600" kern="1200">
+                <a:solidFill>
+                  <a:schemeClr val="tx1"/>
+                </a:solidFill>
+                <a:latin typeface="+mn-lt"/>
+                <a:ea typeface="+mn-ea"/>
+                <a:cs typeface="+mn-cs"/>
+              </a:defRPr>
+            </a:lvl9pPr>
+          </a:lstStyle>
+          <a:p>
+            <a:r>
+              <a:rPr lang="sv-SE" dirty="0"/>
+              <a:t>3 BUGGAR!</a:t>
+            </a:r>
+          </a:p>
+          <a:p>
+            <a:r>
+              <a:rPr lang="sv-SE" dirty="0" err="1"/>
+              <a:t>lw</a:t>
+            </a:r>
+            <a:r>
+              <a:rPr lang="sv-SE" dirty="0"/>
+              <a:t> istället för </a:t>
+            </a:r>
+            <a:r>
+              <a:rPr lang="sv-SE" dirty="0" err="1"/>
+              <a:t>lh</a:t>
+            </a:r>
+            <a:endParaRPr lang="sv-SE" dirty="0"/>
+          </a:p>
+          <a:p>
+            <a:r>
+              <a:rPr lang="sv-SE" dirty="0"/>
+              <a:t>10 istället för </a:t>
+            </a:r>
+            <a:r>
+              <a:rPr lang="sv-SE" dirty="0" err="1"/>
+              <a:t>size</a:t>
+            </a:r>
+            <a:endParaRPr lang="sv-SE" dirty="0"/>
+          </a:p>
+          <a:p>
+            <a:r>
+              <a:rPr lang="sv-SE" dirty="0" err="1"/>
+              <a:t>sum</a:t>
+            </a:r>
+            <a:r>
+              <a:rPr lang="sv-SE" dirty="0"/>
+              <a:t> funktionen klarar inte en lista med </a:t>
+            </a:r>
+            <a:r>
+              <a:rPr lang="sv-SE"/>
+              <a:t>0 element!!</a:t>
+            </a:r>
+            <a:endParaRPr lang="sv-SE" dirty="0"/>
+          </a:p>
+          <a:p>
+            <a:endParaRPr lang="LID4096" dirty="0"/>
           </a:p>
         </p:txBody>
       </p:sp>
@@ -8091,7 +8434,9 @@
         </p:nvSpPr>
         <p:spPr/>
         <p:txBody>
-          <a:bodyPr/>
+          <a:bodyPr>
+            <a:normAutofit lnSpcReduction="10000"/>
+          </a:bodyPr>
           <a:lstStyle/>
           <a:p>
             <a:pPr marL="0" indent="0">

</xml_diff>